<commit_message>
Rename the product to §pecs
Demo, slides, presenter script, pitch deck and judge portal now show
§pecs (spoken "Specs") instead of ITSG Spec Pipeline. File names stay
the same so existing links keep working.

Co-Authored-By: Claude Opus 5.5 <noreply@anthropic.com>
</commit_message>
<xml_diff>
--- a/pitch/ITSG-Spec-Pipeline.pptx
+++ b/pitch/ITSG-Spec-Pipeline.pptx
@@ -506,7 +506,7 @@
           <a:lstStyle/>
           <a:p>
             <a:r>
-              <a:t>We built ITSG Spec Pipeline for the ITSG challenge.</a:t>
+              <a:t>We built §pecs for the ITSG challenge.</a:t>
             </a:r>
           </a:p>
           <a:p>
@@ -731,7 +731,7 @@
           <a:lstStyle/>
           <a:p>
             <a:r>
-              <a:t>ITSG Spec Pipeline: the AI reads and drafts, you approve, tested code calculates.</a:t>
+              <a:t>§pecs: the AI reads and drafts, you approve, tested code calculates.</a:t>
             </a:r>
           </a:p>
           <a:p>
@@ -3894,7 +3894,7 @@
                 </a:solidFill>
                 <a:latin typeface="Arial Narrow"/>
               </a:rPr>
-              <a:t>ITSG Spec Pipeline</a:t>
+              <a:t>§pecs</a:t>
             </a:r>
           </a:p>
         </p:txBody>
@@ -5106,7 +5106,7 @@
                 </a:solidFill>
                 <a:latin typeface="Arial Narrow"/>
               </a:rPr>
-              <a:t>ITSG Spec Pipeline</a:t>
+              <a:t>§pecs</a:t>
             </a:r>
           </a:p>
         </p:txBody>

</xml_diff>